<commit_message>
delivery: strip literal markdown from rendered slide text across S1 (render-safety pass)
Co-Authored-By: Claude Fable 5 <noreply@anthropic.com>
</commit_message>
<xml_diff>
--- a/S1-CL2-Cloud-Disaster-Recovery/delivery/topic_06/Topic_06_Slides.pptx
+++ b/S1-CL2-Cloud-Disaster-Recovery/delivery/topic_06/Topic_06_Slides.pptx
@@ -5856,7 +5856,7 @@
                 </a:solidFill>
                 <a:latin typeface="Roboto"/>
               </a:rPr>
-              <a:t>Deploy the provided template in the lab (Region us-east-1 — `[scenario: ap-southeast-2 (Sydney) | deploy: us-east-1]`).</a:t>
+              <a:t>Deploy the provided template in the lab (Region us-east-1 — [scenario: ap-southeast-2 (Sydney) | deploy: us-east-1]).</a:t>
             </a:r>
           </a:p>
           <a:p>
@@ -8989,7 +8989,7 @@
                 </a:solidFill>
                 <a:latin typeface="Roboto"/>
               </a:rPr>
-              <a:t>Region substitution starts here: the design targets Sydney/India, but you deploy to us-east-1 — `[scenario: ap-southeast-2 (Sydney) | deploy: us-east-1]`. Same build, only the console Region differs.</a:t>
+              <a:t>Region substitution starts here: the design targets Sydney/India, but you deploy to us-east-1 — [scenario: ap-southeast-2 (Sydney) | deploy: us-east-1]. Same build, only the console Region differs.</a:t>
             </a:r>
           </a:p>
           <a:p>
@@ -9020,7 +9020,7 @@
                 </a:solidFill>
                 <a:latin typeface="Roboto"/>
               </a:rPr>
-              <a:t>`teach → demo → practice`: watch the demo, then do it on the practice scenario.</a:t>
+              <a:t>teach → demo → practice: watch the demo, then do it on the practice scenario.</a:t>
             </a:r>
           </a:p>
         </p:txBody>
@@ -10592,7 +10592,7 @@
                 </a:solidFill>
                 <a:latin typeface="Roboto"/>
               </a:rPr>
-              <a:t>The parts: Parameters (inputs), Resources (what to create), Outputs (what to share), intrinsic functions (`!Ref`, `!GetAtt`, `!Sub`).</a:t>
+              <a:t>The parts: Parameters (inputs), Resources (what to create), Outputs (what to share), intrinsic functions (!Ref, !GetAtt, !Sub).</a:t>
             </a:r>
           </a:p>
           <a:p>
@@ -10965,7 +10965,7 @@
                 </a:solidFill>
                 <a:latin typeface="Roboto"/>
               </a:rPr>
-              <a:t>Trace `!Ref`/`!GetAtt` to see what depends on what — the build order falls out of the references.</a:t>
+              <a:t>Trace !Ref/!GetAtt to see what depends on what — the build order falls out of the references.</a:t>
             </a:r>
           </a:p>
           <a:p>

</xml_diff>